<commit_message>
Patch hero switched to option 3 Objective reticle (9B)
Objective reticle (ring, crossing sight ticks, red centre) now the
primary patch centre per direction; focus-point centre kept as the
alternative. Tonal and single-ink variants and size ladder follow the
hero.

Co-Authored-By: Claude Fable 5 <noreply@anthropic.com>
Claude-Session: https://claude.ai/code/session_01YLo1WfwUDkbwfJEF3ZNVbB
</commit_message>
<xml_diff>
--- a/output/combat-mindset-patch-reticle.pptx
+++ b/output/combat-mindset-patch-reticle.pptx
@@ -1253,7 +1253,7 @@
                 <a:ea typeface="Arial" pitchFamily="34" charset="-122"/>
                 <a:cs typeface="Arial" pitchFamily="34" charset="-120"/>
               </a:rPr>
-              <a:t>9A  FOCUS POINT PATCH</a:t>
+              <a:t>9B  OBJECTIVE PATCH</a:t>
             </a:r>
             <a:endParaRPr lang="en-US" sz="1100" dirty="0"/>
           </a:p>
@@ -1292,7 +1292,7 @@
                 <a:ea typeface="Arial" pitchFamily="34" charset="-122"/>
                 <a:cs typeface="Arial" pitchFamily="34" charset="-120"/>
               </a:rPr>
-              <a:t>The clean focus-point reticle at the heart of the patch: a broken ring gathering on a single red centre — focus held under pressure. No weapons, no letters; one idea.</a:t>
+              <a:t>The clean objective reticle at the heart of the patch: sight ticks crossing the ring on a single red centre — the mission remains the centre. No weapons, no letters; one idea.</a:t>
             </a:r>
             <a:endParaRPr lang="en-US" sz="800" dirty="0"/>
           </a:p>
@@ -1380,7 +1380,7 @@
                 <a:ea typeface="Arial" pitchFamily="34" charset="-122"/>
                 <a:cs typeface="Arial" pitchFamily="34" charset="-120"/>
               </a:rPr>
-              <a:t>alternative — objective centre</a:t>
+              <a:t>alternative — focus-point centre</a:t>
             </a:r>
             <a:endParaRPr lang="en-US" sz="680" dirty="0"/>
           </a:p>
@@ -1681,7 +1681,7 @@
                 <a:ea typeface="Arial" pitchFamily="34" charset="-122"/>
                 <a:cs typeface="Arial" pitchFamily="34" charset="-120"/>
               </a:rPr>
-              <a:t>Centre reticle drawn from the clean brandmark exploration (focus point; objective offered as alternative).</a:t>
+              <a:t>Centre reticle drawn from the clean brandmark exploration, option 3 — Objective (focus point offered as alternative).</a:t>
             </a:r>
             <a:endParaRPr lang="en-US" sz="740" dirty="0"/>
           </a:p>

</xml_diff>